<commit_message>
docs: update project reports and posters and add new references to the final report bibliography
</commit_message>
<xml_diff>
--- a/docs/Final_Poster.pptx
+++ b/docs/Final_Poster.pptx
@@ -4219,7 +4219,7 @@
         <p:spPr>
           <a:xfrm>
             <a:off x="15547520" y="36558580"/>
-            <a:ext cx="14197058" cy="3721073"/>
+            <a:ext cx="14197058" cy="3875244"/>
           </a:xfrm>
           <a:prstGeom prst="rect">
             <a:avLst/>
@@ -4257,14 +4257,44 @@
               </a:spcAft>
             </a:pPr>
             <a:r>
-              <a:rPr sz="2600" b="0" dirty="0">
-                <a:solidFill>
-                  <a:srgbClr val="333333"/>
+              <a:rPr lang="en-US" sz="2600" dirty="0">
+                <a:solidFill>
+                  <a:schemeClr val="tx1"/>
                 </a:solidFill>
                 <a:latin typeface="Times New Roman" panose="02020603050405020304" pitchFamily="18" charset="0"/>
                 <a:cs typeface="Times New Roman" panose="02020603050405020304" pitchFamily="18" charset="0"/>
               </a:rPr>
-              <a:t>[1] Zhong et al. (2017). Seq2SQL. arXiv:1709.00103.</a:t>
+              <a:t>[1] V. Zhong, C. Xiong, and R. Socher, "Seq2SQL: Generating structured queries from natural language using reinforcement learning," </a:t>
+            </a:r>
+            <a:r>
+              <a:rPr lang="en-US" sz="2600" i="1" dirty="0" err="1">
+                <a:solidFill>
+                  <a:schemeClr val="tx1"/>
+                </a:solidFill>
+                <a:latin typeface="Times New Roman" panose="02020603050405020304" pitchFamily="18" charset="0"/>
+                <a:cs typeface="Times New Roman" panose="02020603050405020304" pitchFamily="18" charset="0"/>
+              </a:rPr>
+              <a:t>arXiv</a:t>
+            </a:r>
+            <a:r>
+              <a:rPr lang="en-US" sz="2600" i="1" dirty="0">
+                <a:solidFill>
+                  <a:schemeClr val="tx1"/>
+                </a:solidFill>
+                <a:latin typeface="Times New Roman" panose="02020603050405020304" pitchFamily="18" charset="0"/>
+                <a:cs typeface="Times New Roman" panose="02020603050405020304" pitchFamily="18" charset="0"/>
+              </a:rPr>
+              <a:t> preprint arXiv:1709.00103</a:t>
+            </a:r>
+            <a:r>
+              <a:rPr lang="en-US" sz="2600" dirty="0">
+                <a:solidFill>
+                  <a:schemeClr val="tx1"/>
+                </a:solidFill>
+                <a:latin typeface="Times New Roman" panose="02020603050405020304" pitchFamily="18" charset="0"/>
+                <a:cs typeface="Times New Roman" panose="02020603050405020304" pitchFamily="18" charset="0"/>
+              </a:rPr>
+              <a:t>, 2017. </a:t>
             </a:r>
           </a:p>
           <a:p>
@@ -4274,14 +4304,54 @@
               </a:spcAft>
             </a:pPr>
             <a:r>
-              <a:rPr sz="2600" b="0" dirty="0">
-                <a:solidFill>
-                  <a:srgbClr val="333333"/>
+              <a:rPr lang="en-US" sz="2600" dirty="0">
+                <a:solidFill>
+                  <a:schemeClr val="tx1"/>
                 </a:solidFill>
                 <a:latin typeface="Times New Roman" panose="02020603050405020304" pitchFamily="18" charset="0"/>
                 <a:cs typeface="Times New Roman" panose="02020603050405020304" pitchFamily="18" charset="0"/>
               </a:rPr>
-              <a:t>[2] Yu et al. (2018). Spider: Complex Text-to-SQL. EMNLP.</a:t>
+              <a:t>[2] T. Yu et al., "Spider: A large-scale human-labeled dataset for complex and cross-domain semantic parsing and text-to-</a:t>
+            </a:r>
+            <a:r>
+              <a:rPr lang="en-US" sz="2600" dirty="0" err="1">
+                <a:solidFill>
+                  <a:schemeClr val="tx1"/>
+                </a:solidFill>
+                <a:latin typeface="Times New Roman" panose="02020603050405020304" pitchFamily="18" charset="0"/>
+                <a:cs typeface="Times New Roman" panose="02020603050405020304" pitchFamily="18" charset="0"/>
+              </a:rPr>
+              <a:t>sql</a:t>
+            </a:r>
+            <a:r>
+              <a:rPr lang="en-US" sz="2600" dirty="0">
+                <a:solidFill>
+                  <a:schemeClr val="tx1"/>
+                </a:solidFill>
+                <a:latin typeface="Times New Roman" panose="02020603050405020304" pitchFamily="18" charset="0"/>
+                <a:cs typeface="Times New Roman" panose="02020603050405020304" pitchFamily="18" charset="0"/>
+              </a:rPr>
+              <a:t> task," in </a:t>
+            </a:r>
+            <a:r>
+              <a:rPr lang="en-US" sz="2600" i="1" dirty="0">
+                <a:solidFill>
+                  <a:schemeClr val="tx1"/>
+                </a:solidFill>
+                <a:latin typeface="Times New Roman" panose="02020603050405020304" pitchFamily="18" charset="0"/>
+                <a:cs typeface="Times New Roman" panose="02020603050405020304" pitchFamily="18" charset="0"/>
+              </a:rPr>
+              <a:t>Proc. EMNLP</a:t>
+            </a:r>
+            <a:r>
+              <a:rPr lang="en-US" sz="2600" dirty="0">
+                <a:solidFill>
+                  <a:schemeClr val="tx1"/>
+                </a:solidFill>
+                <a:latin typeface="Times New Roman" panose="02020603050405020304" pitchFamily="18" charset="0"/>
+                <a:cs typeface="Times New Roman" panose="02020603050405020304" pitchFamily="18" charset="0"/>
+              </a:rPr>
+              <a:t>, 2018. </a:t>
             </a:r>
           </a:p>
           <a:p>
@@ -4291,34 +4361,64 @@
               </a:spcAft>
             </a:pPr>
             <a:r>
-              <a:rPr sz="2600" b="0" dirty="0">
-                <a:solidFill>
-                  <a:srgbClr val="333333"/>
+              <a:rPr lang="en-US" sz="2600" dirty="0">
+                <a:solidFill>
+                  <a:schemeClr val="tx1"/>
                 </a:solidFill>
                 <a:latin typeface="Times New Roman" panose="02020603050405020304" pitchFamily="18" charset="0"/>
                 <a:cs typeface="Times New Roman" panose="02020603050405020304" pitchFamily="18" charset="0"/>
               </a:rPr>
-              <a:t>[3] Li et al. (2023). BIRD Benchmark. </a:t>
-            </a:r>
-            <a:r>
-              <a:rPr sz="2600" b="0" dirty="0" err="1">
-                <a:solidFill>
-                  <a:srgbClr val="333333"/>
+              <a:t>[3] J. Li et al., "Can LLM already serve as a database interface? A </a:t>
+            </a:r>
+            <a:r>
+              <a:rPr lang="en-US" sz="2600" dirty="0" err="1">
+                <a:solidFill>
+                  <a:schemeClr val="tx1"/>
                 </a:solidFill>
                 <a:latin typeface="Times New Roman" panose="02020603050405020304" pitchFamily="18" charset="0"/>
                 <a:cs typeface="Times New Roman" panose="02020603050405020304" pitchFamily="18" charset="0"/>
               </a:rPr>
-              <a:t>NeurIPS</a:t>
-            </a:r>
-            <a:r>
-              <a:rPr sz="2600" b="0" dirty="0">
-                <a:solidFill>
-                  <a:srgbClr val="333333"/>
+              <a:t>BIg</a:t>
+            </a:r>
+            <a:r>
+              <a:rPr lang="en-US" sz="2600" dirty="0">
+                <a:solidFill>
+                  <a:schemeClr val="tx1"/>
                 </a:solidFill>
                 <a:latin typeface="Times New Roman" panose="02020603050405020304" pitchFamily="18" charset="0"/>
                 <a:cs typeface="Times New Roman" panose="02020603050405020304" pitchFamily="18" charset="0"/>
               </a:rPr>
-              <a:t>.</a:t>
+              <a:t> Bench for Large-Scale Database Grounded Text-to-SQLs," in </a:t>
+            </a:r>
+            <a:r>
+              <a:rPr lang="en-US" sz="2600" i="1" dirty="0">
+                <a:solidFill>
+                  <a:schemeClr val="tx1"/>
+                </a:solidFill>
+                <a:latin typeface="Times New Roman" panose="02020603050405020304" pitchFamily="18" charset="0"/>
+                <a:cs typeface="Times New Roman" panose="02020603050405020304" pitchFamily="18" charset="0"/>
+              </a:rPr>
+              <a:t>Proc. </a:t>
+            </a:r>
+            <a:r>
+              <a:rPr lang="en-US" sz="2600" i="1" dirty="0" err="1">
+                <a:solidFill>
+                  <a:schemeClr val="tx1"/>
+                </a:solidFill>
+                <a:latin typeface="Times New Roman" panose="02020603050405020304" pitchFamily="18" charset="0"/>
+                <a:cs typeface="Times New Roman" panose="02020603050405020304" pitchFamily="18" charset="0"/>
+              </a:rPr>
+              <a:t>NeurIPS</a:t>
+            </a:r>
+            <a:r>
+              <a:rPr lang="en-US" sz="2600" dirty="0">
+                <a:solidFill>
+                  <a:schemeClr val="tx1"/>
+                </a:solidFill>
+                <a:latin typeface="Times New Roman" panose="02020603050405020304" pitchFamily="18" charset="0"/>
+                <a:cs typeface="Times New Roman" panose="02020603050405020304" pitchFamily="18" charset="0"/>
+              </a:rPr>
+              <a:t>, 2023. </a:t>
             </a:r>
           </a:p>
           <a:p>
@@ -4328,19 +4428,19 @@
               </a:spcAft>
             </a:pPr>
             <a:r>
-              <a:rPr sz="2600" b="0" dirty="0">
-                <a:solidFill>
-                  <a:srgbClr val="333333"/>
+              <a:rPr lang="en-US" sz="2600" dirty="0">
+                <a:solidFill>
+                  <a:schemeClr val="tx1"/>
                 </a:solidFill>
                 <a:latin typeface="Times New Roman" panose="02020603050405020304" pitchFamily="18" charset="0"/>
                 <a:cs typeface="Times New Roman" panose="02020603050405020304" pitchFamily="18" charset="0"/>
               </a:rPr>
-              <a:t>[4] Chang et al. (2023). </a:t>
-            </a:r>
-            <a:r>
-              <a:rPr sz="2600" b="0" dirty="0" err="1">
-                <a:solidFill>
-                  <a:srgbClr val="333333"/>
+              <a:t>[4] S. Chang et al., "</a:t>
+            </a:r>
+            <a:r>
+              <a:rPr lang="en-US" sz="2600" dirty="0" err="1">
+                <a:solidFill>
+                  <a:schemeClr val="tx1"/>
                 </a:solidFill>
                 <a:latin typeface="Times New Roman" panose="02020603050405020304" pitchFamily="18" charset="0"/>
                 <a:cs typeface="Times New Roman" panose="02020603050405020304" pitchFamily="18" charset="0"/>
@@ -4348,107 +4448,79 @@
               <a:t>Dr.Spider</a:t>
             </a:r>
             <a:r>
-              <a:rPr sz="2600" b="0" dirty="0">
-                <a:solidFill>
-                  <a:srgbClr val="333333"/>
+              <a:rPr lang="en-US" sz="2600" dirty="0">
+                <a:solidFill>
+                  <a:schemeClr val="tx1"/>
                 </a:solidFill>
                 <a:latin typeface="Times New Roman" panose="02020603050405020304" pitchFamily="18" charset="0"/>
                 <a:cs typeface="Times New Roman" panose="02020603050405020304" pitchFamily="18" charset="0"/>
               </a:rPr>
-              <a:t>. ICLR.</a:t>
-            </a:r>
-          </a:p>
-          <a:p>
-            <a:pPr algn="just">
-              <a:spcAft>
-                <a:spcPts val="400"/>
-              </a:spcAft>
-            </a:pPr>
-            <a:r>
-              <a:rPr sz="2600" b="0" dirty="0">
-                <a:solidFill>
-                  <a:srgbClr val="333333"/>
+              <a:t>: A diagnostic evaluation benchmark for robust text-to-</a:t>
+            </a:r>
+            <a:r>
+              <a:rPr lang="en-US" sz="2600" dirty="0" err="1">
+                <a:solidFill>
+                  <a:schemeClr val="tx1"/>
                 </a:solidFill>
                 <a:latin typeface="Times New Roman" panose="02020603050405020304" pitchFamily="18" charset="0"/>
                 <a:cs typeface="Times New Roman" panose="02020603050405020304" pitchFamily="18" charset="0"/>
               </a:rPr>
-              <a:t>[5] Jiao et al. (2026). </a:t>
-            </a:r>
-            <a:r>
-              <a:rPr sz="2600" b="0" dirty="0" err="1">
-                <a:solidFill>
-                  <a:srgbClr val="333333"/>
+              <a:t>sql</a:t>
+            </a:r>
+            <a:r>
+              <a:rPr lang="en-US" sz="2600" dirty="0">
+                <a:solidFill>
+                  <a:schemeClr val="tx1"/>
                 </a:solidFill>
                 <a:latin typeface="Times New Roman" panose="02020603050405020304" pitchFamily="18" charset="0"/>
                 <a:cs typeface="Times New Roman" panose="02020603050405020304" pitchFamily="18" charset="0"/>
               </a:rPr>
-              <a:t>GeoSQL</a:t>
-            </a:r>
-            <a:r>
-              <a:rPr sz="2600" b="0" dirty="0">
-                <a:solidFill>
-                  <a:srgbClr val="333333"/>
+              <a:t>," in </a:t>
+            </a:r>
+            <a:r>
+              <a:rPr lang="en-US" sz="2600" i="1" dirty="0">
+                <a:solidFill>
+                  <a:schemeClr val="tx1"/>
                 </a:solidFill>
                 <a:latin typeface="Times New Roman" panose="02020603050405020304" pitchFamily="18" charset="0"/>
                 <a:cs typeface="Times New Roman" panose="02020603050405020304" pitchFamily="18" charset="0"/>
               </a:rPr>
-              <a:t>-Eval. Expert Systems.</a:t>
-            </a:r>
-          </a:p>
-          <a:p>
-            <a:pPr algn="just">
-              <a:spcAft>
-                <a:spcPts val="400"/>
-              </a:spcAft>
-            </a:pPr>
-            <a:r>
-              <a:rPr sz="2600" b="0" dirty="0">
-                <a:solidFill>
-                  <a:srgbClr val="333333"/>
+              <a:t>Proc. ICLR</a:t>
+            </a:r>
+            <a:r>
+              <a:rPr lang="en-US" sz="2600" dirty="0">
+                <a:solidFill>
+                  <a:schemeClr val="tx1"/>
                 </a:solidFill>
                 <a:latin typeface="Times New Roman" panose="02020603050405020304" pitchFamily="18" charset="0"/>
                 <a:cs typeface="Times New Roman" panose="02020603050405020304" pitchFamily="18" charset="0"/>
               </a:rPr>
-              <a:t>[6] Alibaba (2024). Qwen2.5-Coder.</a:t>
-            </a:r>
-          </a:p>
-          <a:p>
-            <a:pPr algn="just">
-              <a:spcAft>
-                <a:spcPts val="400"/>
-              </a:spcAft>
-            </a:pPr>
-            <a:r>
-              <a:rPr sz="2600" b="0" dirty="0">
-                <a:solidFill>
-                  <a:srgbClr val="333333"/>
+              <a:t>, 2023. [5] H. Jiao et al., "</a:t>
+            </a:r>
+            <a:r>
+              <a:rPr lang="en-US" sz="2600" dirty="0" err="1">
+                <a:solidFill>
+                  <a:schemeClr val="tx1"/>
                 </a:solidFill>
                 <a:latin typeface="Times New Roman" panose="02020603050405020304" pitchFamily="18" charset="0"/>
                 <a:cs typeface="Times New Roman" panose="02020603050405020304" pitchFamily="18" charset="0"/>
               </a:rPr>
-              <a:t>[7] Sarvam AI (2024). Sarvam-Translate.</a:t>
-            </a:r>
-          </a:p>
-          <a:p>
-            <a:pPr algn="just">
-              <a:spcAft>
-                <a:spcPts val="400"/>
-              </a:spcAft>
-            </a:pPr>
-            <a:r>
-              <a:rPr sz="2600" b="0" dirty="0">
-                <a:solidFill>
-                  <a:srgbClr val="333333"/>
+              <a:t>GeoSQL</a:t>
+            </a:r>
+            <a:r>
+              <a:rPr lang="en-US" sz="2600" dirty="0">
+                <a:solidFill>
+                  <a:schemeClr val="tx1"/>
                 </a:solidFill>
                 <a:latin typeface="Times New Roman" panose="02020603050405020304" pitchFamily="18" charset="0"/>
                 <a:cs typeface="Times New Roman" panose="02020603050405020304" pitchFamily="18" charset="0"/>
               </a:rPr>
-              <a:t>[8] </a:t>
-            </a:r>
-            <a:r>
-              <a:rPr sz="2600" b="0" dirty="0" err="1">
-                <a:solidFill>
-                  <a:srgbClr val="333333"/>
+              <a:t>-Eval: First evaluation of LLMs on </a:t>
+            </a:r>
+            <a:r>
+              <a:rPr lang="en-US" sz="2600" dirty="0" err="1">
+                <a:solidFill>
+                  <a:schemeClr val="tx1"/>
                 </a:solidFill>
                 <a:latin typeface="Times New Roman" panose="02020603050405020304" pitchFamily="18" charset="0"/>
                 <a:cs typeface="Times New Roman" panose="02020603050405020304" pitchFamily="18" charset="0"/>
@@ -4456,28 +4528,38 @@
               <a:t>PostGIS</a:t>
             </a:r>
             <a:r>
-              <a:rPr sz="2600" b="0" dirty="0">
-                <a:solidFill>
-                  <a:srgbClr val="333333"/>
+              <a:rPr lang="en-US" sz="2600" dirty="0">
+                <a:solidFill>
+                  <a:schemeClr val="tx1"/>
                 </a:solidFill>
                 <a:latin typeface="Times New Roman" panose="02020603050405020304" pitchFamily="18" charset="0"/>
                 <a:cs typeface="Times New Roman" panose="02020603050405020304" pitchFamily="18" charset="0"/>
               </a:rPr>
-              <a:t> Development Group. </a:t>
-            </a:r>
-            <a:r>
-              <a:rPr sz="2600" b="0" dirty="0" err="1">
-                <a:solidFill>
-                  <a:srgbClr val="333333"/>
+              <a:t>-based NL2GeoSQL queries," </a:t>
+            </a:r>
+            <a:r>
+              <a:rPr lang="en-US" sz="2600" i="1" dirty="0">
+                <a:solidFill>
+                  <a:schemeClr val="tx1"/>
                 </a:solidFill>
                 <a:latin typeface="Times New Roman" panose="02020603050405020304" pitchFamily="18" charset="0"/>
                 <a:cs typeface="Times New Roman" panose="02020603050405020304" pitchFamily="18" charset="0"/>
               </a:rPr>
-              <a:t>postgis.net</a:t>
+              <a:t>Expert Syst. Appl.</a:t>
+            </a:r>
+            <a:r>
+              <a:rPr lang="en-US" sz="2600" dirty="0">
+                <a:solidFill>
+                  <a:schemeClr val="tx1"/>
+                </a:solidFill>
+                <a:latin typeface="Times New Roman" panose="02020603050405020304" pitchFamily="18" charset="0"/>
+                <a:cs typeface="Times New Roman" panose="02020603050405020304" pitchFamily="18" charset="0"/>
+              </a:rPr>
+              <a:t>, 2026.</a:t>
             </a:r>
             <a:endParaRPr sz="2600" b="0" dirty="0">
               <a:solidFill>
-                <a:srgbClr val="333333"/>
+                <a:schemeClr val="tx1"/>
               </a:solidFill>
               <a:latin typeface="Times New Roman" panose="02020603050405020304" pitchFamily="18" charset="0"/>
               <a:cs typeface="Times New Roman" panose="02020603050405020304" pitchFamily="18" charset="0"/>
@@ -8224,7 +8306,7 @@
         <p:spPr>
           <a:xfrm>
             <a:off x="872966" y="35323004"/>
-            <a:ext cx="14356080" cy="4950746"/>
+            <a:ext cx="14356080" cy="5086824"/>
           </a:xfrm>
           <a:prstGeom prst="rect">
             <a:avLst/>
@@ -8283,8 +8365,8 @@
         </p:blipFill>
         <p:spPr>
           <a:xfrm>
-            <a:off x="899544" y="35343364"/>
-            <a:ext cx="14238062" cy="4902643"/>
+            <a:off x="945264" y="35356082"/>
+            <a:ext cx="14238062" cy="5008237"/>
           </a:xfrm>
           <a:prstGeom prst="rect">
             <a:avLst/>
@@ -8516,14 +8598,7 @@
                 <a:latin typeface="Times New Roman" panose="02020603050405020304" pitchFamily="18" charset="0"/>
                 <a:cs typeface="Times New Roman" panose="02020603050405020304" pitchFamily="18" charset="0"/>
               </a:rPr>
-              <a:t>Institute Name: Newton School of Technology		              				  </a:t>
-            </a:r>
-            <a:r>
-              <a:rPr lang="en-US" sz="4500" b="1" dirty="0" err="1">
-                <a:latin typeface="Times New Roman" panose="02020603050405020304" pitchFamily="18" charset="0"/>
-                <a:cs typeface="Times New Roman" panose="02020603050405020304" pitchFamily="18" charset="0"/>
-              </a:rPr>
-              <a:t>Department:CSIS</a:t>
+              <a:t>Institute Name: Newton School of Technology		              				  Department: CSIS</a:t>
             </a:r>
             <a:endParaRPr lang="en-US" sz="4500" b="1" i="1" baseline="30000" dirty="0">
               <a:latin typeface="Times New Roman" panose="02020603050405020304" pitchFamily="18" charset="0"/>

</xml_diff>

<commit_message>
feat: add BITS Pilani benchmark dataset and evaluation results for multiple models while cleaning up documentation and notebooks
</commit_message>
<xml_diff>
--- a/docs/Final_Poster.pptx
+++ b/docs/Final_Poster.pptx
@@ -197,7 +197,7 @@
           <a:p>
             <a:fld id="{A0C2BA6F-6457-439F-BBDB-0B38AEA84A6F}" type="datetimeFigureOut">
               <a:rPr lang="en-US" smtClean="0"/>
-              <a:t>7/7/26</a:t>
+              <a:t>7/10/26</a:t>
             </a:fld>
             <a:endParaRPr lang="en-US"/>
           </a:p>
@@ -684,7 +684,7 @@
           <a:p>
             <a:fld id="{43F7F64B-FB45-4607-AAFE-E64E652CDD08}" type="datetimeFigureOut">
               <a:rPr lang="en-US" smtClean="0"/>
-              <a:t>7/7/26</a:t>
+              <a:t>7/10/26</a:t>
             </a:fld>
             <a:endParaRPr lang="en-US"/>
           </a:p>
@@ -854,7 +854,7 @@
           <a:p>
             <a:fld id="{43F7F64B-FB45-4607-AAFE-E64E652CDD08}" type="datetimeFigureOut">
               <a:rPr lang="en-US" smtClean="0"/>
-              <a:t>7/7/26</a:t>
+              <a:t>7/10/26</a:t>
             </a:fld>
             <a:endParaRPr lang="en-US"/>
           </a:p>
@@ -1034,7 +1034,7 @@
           <a:p>
             <a:fld id="{43F7F64B-FB45-4607-AAFE-E64E652CDD08}" type="datetimeFigureOut">
               <a:rPr lang="en-US" smtClean="0"/>
-              <a:t>7/7/26</a:t>
+              <a:t>7/10/26</a:t>
             </a:fld>
             <a:endParaRPr lang="en-US"/>
           </a:p>
@@ -1204,7 +1204,7 @@
           <a:p>
             <a:fld id="{43F7F64B-FB45-4607-AAFE-E64E652CDD08}" type="datetimeFigureOut">
               <a:rPr lang="en-US" smtClean="0"/>
-              <a:t>7/7/26</a:t>
+              <a:t>7/10/26</a:t>
             </a:fld>
             <a:endParaRPr lang="en-US"/>
           </a:p>
@@ -1448,7 +1448,7 @@
           <a:p>
             <a:fld id="{43F7F64B-FB45-4607-AAFE-E64E652CDD08}" type="datetimeFigureOut">
               <a:rPr lang="en-US" smtClean="0"/>
-              <a:t>7/7/26</a:t>
+              <a:t>7/10/26</a:t>
             </a:fld>
             <a:endParaRPr lang="en-US"/>
           </a:p>
@@ -1680,7 +1680,7 @@
           <a:p>
             <a:fld id="{43F7F64B-FB45-4607-AAFE-E64E652CDD08}" type="datetimeFigureOut">
               <a:rPr lang="en-US" smtClean="0"/>
-              <a:t>7/7/26</a:t>
+              <a:t>7/10/26</a:t>
             </a:fld>
             <a:endParaRPr lang="en-US"/>
           </a:p>
@@ -2047,7 +2047,7 @@
           <a:p>
             <a:fld id="{43F7F64B-FB45-4607-AAFE-E64E652CDD08}" type="datetimeFigureOut">
               <a:rPr lang="en-US" smtClean="0"/>
-              <a:t>7/7/26</a:t>
+              <a:t>7/10/26</a:t>
             </a:fld>
             <a:endParaRPr lang="en-US"/>
           </a:p>
@@ -2165,7 +2165,7 @@
           <a:p>
             <a:fld id="{43F7F64B-FB45-4607-AAFE-E64E652CDD08}" type="datetimeFigureOut">
               <a:rPr lang="en-US" smtClean="0"/>
-              <a:t>7/7/26</a:t>
+              <a:t>7/10/26</a:t>
             </a:fld>
             <a:endParaRPr lang="en-US"/>
           </a:p>
@@ -2260,7 +2260,7 @@
           <a:p>
             <a:fld id="{43F7F64B-FB45-4607-AAFE-E64E652CDD08}" type="datetimeFigureOut">
               <a:rPr lang="en-US" smtClean="0"/>
-              <a:t>7/7/26</a:t>
+              <a:t>7/10/26</a:t>
             </a:fld>
             <a:endParaRPr lang="en-US"/>
           </a:p>
@@ -2537,7 +2537,7 @@
           <a:p>
             <a:fld id="{43F7F64B-FB45-4607-AAFE-E64E652CDD08}" type="datetimeFigureOut">
               <a:rPr lang="en-US" smtClean="0"/>
-              <a:t>7/7/26</a:t>
+              <a:t>7/10/26</a:t>
             </a:fld>
             <a:endParaRPr lang="en-US"/>
           </a:p>
@@ -2794,7 +2794,7 @@
           <a:p>
             <a:fld id="{43F7F64B-FB45-4607-AAFE-E64E652CDD08}" type="datetimeFigureOut">
               <a:rPr lang="en-US" smtClean="0"/>
-              <a:t>7/7/26</a:t>
+              <a:t>7/10/26</a:t>
             </a:fld>
             <a:endParaRPr lang="en-US"/>
           </a:p>
@@ -3007,7 +3007,7 @@
           <a:p>
             <a:fld id="{43F7F64B-FB45-4607-AAFE-E64E652CDD08}" type="datetimeFigureOut">
               <a:rPr lang="en-US" smtClean="0"/>
-              <a:t>7/7/26</a:t>
+              <a:t>7/10/26</a:t>
             </a:fld>
             <a:endParaRPr lang="en-US"/>
           </a:p>
@@ -3588,8 +3588,8 @@
         </p:nvSpPr>
         <p:spPr>
           <a:xfrm>
-            <a:off x="7494375" y="604235"/>
-            <a:ext cx="17031418" cy="1323439"/>
+            <a:off x="7916240" y="700485"/>
+            <a:ext cx="16113760" cy="1323439"/>
           </a:xfrm>
           <a:prstGeom prst="rect">
             <a:avLst/>
@@ -3630,8 +3630,8 @@
         </p:nvSpPr>
         <p:spPr>
           <a:xfrm>
-            <a:off x="8314556" y="1670806"/>
-            <a:ext cx="16968888" cy="707886"/>
+            <a:off x="8077583" y="1870156"/>
+            <a:ext cx="15961047" cy="646331"/>
           </a:xfrm>
           <a:prstGeom prst="rect">
             <a:avLst/>
@@ -3644,8 +3644,9 @@
           </a:bodyPr>
           <a:lstStyle/>
           <a:p>
-            <a:r>
-              <a:rPr lang="en-US" sz="4000" i="1" dirty="0">
+            <a:pPr algn="ctr"/>
+            <a:r>
+              <a:rPr lang="en-US" sz="3600" i="1" dirty="0">
                 <a:solidFill>
                   <a:srgbClr val="002060"/>
                 </a:solidFill>
@@ -3671,8 +3672,8 @@
         </p:nvSpPr>
         <p:spPr>
           <a:xfrm>
-            <a:off x="886255" y="2839855"/>
-            <a:ext cx="14356080" cy="640080"/>
+            <a:off x="886254" y="2839855"/>
+            <a:ext cx="14369369" cy="640080"/>
           </a:xfrm>
           <a:prstGeom prst="rect">
             <a:avLst/>
@@ -3731,7 +3732,7 @@
         <p:spPr>
           <a:xfrm>
             <a:off x="886255" y="3535862"/>
-            <a:ext cx="14356080" cy="5156510"/>
+            <a:ext cx="14369368" cy="4210617"/>
           </a:xfrm>
           <a:prstGeom prst="rect">
             <a:avLst/>
@@ -3763,95 +3764,62 @@
           <a:bodyPr wrap="square" lIns="182880" tIns="137160" rIns="182880" bIns="137160" rtlCol="0" anchor="ctr"/>
           <a:lstStyle/>
           <a:p>
-            <a:pPr algn="just">
-              <a:spcAft>
-                <a:spcPts val="400"/>
-              </a:spcAft>
-            </a:pPr>
+            <a:pPr algn="just"/>
             <a:r>
               <a:rPr lang="en-US" sz="2600" dirty="0">
                 <a:solidFill>
-                  <a:srgbClr val="333333"/>
-                </a:solidFill>
-                <a:latin typeface="Times New Roman"/>
-              </a:rPr>
-              <a:t>Traditional digital maps rely on rigid keyword searches, which fail when users ask for things conversationally. To solve this, we built an Intent-Driven Spatial Search Engine that translates colloquial, multi-lingual queries directly into structured </a:t>
-            </a:r>
-            <a:r>
-              <a:rPr lang="en-US" sz="2600" dirty="0" err="1">
-                <a:solidFill>
-                  <a:srgbClr val="333333"/>
-                </a:solidFill>
-                <a:latin typeface="Times New Roman"/>
-              </a:rPr>
-              <a:t>PostGIS</a:t>
-            </a:r>
-            <a:r>
-              <a:rPr lang="en-US" sz="2600" dirty="0">
-                <a:solidFill>
-                  <a:srgbClr val="333333"/>
-                </a:solidFill>
-                <a:latin typeface="Times New Roman"/>
-              </a:rPr>
-              <a:t> database commands.</a:t>
-            </a:r>
-          </a:p>
-          <a:p>
-            <a:pPr algn="just">
-              <a:spcAft>
-                <a:spcPts val="400"/>
-              </a:spcAft>
-            </a:pPr>
+                  <a:schemeClr val="tx1"/>
+                </a:solidFill>
+                <a:latin typeface="Times New Roman" panose="02020603050405020304" pitchFamily="18" charset="0"/>
+                <a:cs typeface="Times New Roman" panose="02020603050405020304" pitchFamily="18" charset="0"/>
+              </a:rPr>
+              <a:t>Traditional digital maps rely on rigid keyword searches, failing when users ask for places naturally. To solve this, we built an Intent-Driven Spatial Search Engine that translates conversational, multilingual queries directly into structured database commands.</a:t>
+            </a:r>
+          </a:p>
+          <a:p>
+            <a:pPr algn="just"/>
             <a:endParaRPr lang="en-US" sz="2600" dirty="0">
               <a:solidFill>
-                <a:srgbClr val="333333"/>
+                <a:schemeClr val="tx1"/>
               </a:solidFill>
-              <a:latin typeface="Times New Roman"/>
+              <a:latin typeface="Times New Roman" panose="02020603050405020304" pitchFamily="18" charset="0"/>
+              <a:cs typeface="Times New Roman" panose="02020603050405020304" pitchFamily="18" charset="0"/>
             </a:endParaRPr>
           </a:p>
           <a:p>
-            <a:pPr algn="just">
-              <a:spcAft>
-                <a:spcPts val="400"/>
-              </a:spcAft>
-            </a:pPr>
+            <a:pPr algn="just"/>
             <a:r>
               <a:rPr lang="en-US" sz="2600" dirty="0">
                 <a:solidFill>
-                  <a:srgbClr val="333333"/>
-                </a:solidFill>
-                <a:latin typeface="Times New Roman"/>
-              </a:rPr>
-              <a:t>Running 100% offline on a local GPU, the system uses SeamlessM4T for speech recognition and translation, paired with Qwen2.5-Coder to act as a Text-to-SQL engine and intent router.</a:t>
-            </a:r>
-          </a:p>
-          <a:p>
-            <a:pPr algn="just">
-              <a:spcAft>
-                <a:spcPts val="400"/>
-              </a:spcAft>
-            </a:pPr>
+                  <a:schemeClr val="tx1"/>
+                </a:solidFill>
+                <a:latin typeface="Times New Roman" panose="02020603050405020304" pitchFamily="18" charset="0"/>
+                <a:cs typeface="Times New Roman" panose="02020603050405020304" pitchFamily="18" charset="0"/>
+              </a:rPr>
+              <a:t>Running entirely offline on a local GPU, the system combines SeamlessM4T for speech translation with Qwen2.5-Coder for SQL generation.</a:t>
+            </a:r>
+          </a:p>
+          <a:p>
+            <a:pPr algn="just"/>
             <a:endParaRPr lang="en-US" sz="2600" dirty="0">
               <a:solidFill>
-                <a:srgbClr val="333333"/>
+                <a:schemeClr val="tx1"/>
               </a:solidFill>
-              <a:latin typeface="Times New Roman"/>
+              <a:latin typeface="Times New Roman" panose="02020603050405020304" pitchFamily="18" charset="0"/>
+              <a:cs typeface="Times New Roman" panose="02020603050405020304" pitchFamily="18" charset="0"/>
             </a:endParaRPr>
           </a:p>
           <a:p>
-            <a:pPr algn="just">
-              <a:spcAft>
-                <a:spcPts val="400"/>
-              </a:spcAft>
-            </a:pPr>
+            <a:pPr algn="just"/>
             <a:r>
               <a:rPr lang="en-US" sz="2600" b="1" dirty="0">
                 <a:solidFill>
                   <a:srgbClr val="C00000"/>
                 </a:solidFill>
-                <a:latin typeface="Times New Roman"/>
-              </a:rPr>
-              <a:t>Our custom Hybrid Evaluation Framework validates SQL structure (using Abstract Syntax Trees) and live database results. The final architecture achieved a 78.0% success rate on complex geographic intents, proving it can successfully bridge the gap between abstract human intent (like "a quiet place to study") and rigid geographic databases.</a:t>
+                <a:latin typeface="Times New Roman" panose="02020603050405020304" pitchFamily="18" charset="0"/>
+                <a:cs typeface="Times New Roman" panose="02020603050405020304" pitchFamily="18" charset="0"/>
+              </a:rPr>
+              <a:t>Validated by our custom Hybrid Evaluation Framework, the architecture achieved a 78% success rate on complex geographic intents. It successfully bridges the gap between abstract human needs (like "a quiet place to study") and rigid mapping databases.</a:t>
             </a:r>
           </a:p>
         </p:txBody>
@@ -3870,8 +3838,8 @@
         </p:nvSpPr>
         <p:spPr>
           <a:xfrm>
-            <a:off x="886255" y="8757237"/>
-            <a:ext cx="14356080" cy="640080"/>
+            <a:off x="886255" y="7982271"/>
+            <a:ext cx="14369368" cy="640080"/>
           </a:xfrm>
           <a:prstGeom prst="rect">
             <a:avLst/>
@@ -3929,8 +3897,8 @@
         </p:nvSpPr>
         <p:spPr>
           <a:xfrm>
-            <a:off x="886255" y="9488757"/>
-            <a:ext cx="14356080" cy="3291840"/>
+            <a:off x="886255" y="8713791"/>
+            <a:ext cx="14369368" cy="3291840"/>
           </a:xfrm>
           <a:prstGeom prst="rect">
             <a:avLst/>
@@ -4159,8 +4127,8 @@
         </p:nvSpPr>
         <p:spPr>
           <a:xfrm>
-            <a:off x="15547520" y="35810476"/>
-            <a:ext cx="14197058" cy="640080"/>
+            <a:off x="15547501" y="35708834"/>
+            <a:ext cx="14197077" cy="640080"/>
           </a:xfrm>
           <a:prstGeom prst="rect">
             <a:avLst/>
@@ -4218,8 +4186,8 @@
         </p:nvSpPr>
         <p:spPr>
           <a:xfrm>
-            <a:off x="15547520" y="36558580"/>
-            <a:ext cx="14197058" cy="3875244"/>
+            <a:off x="15547501" y="36450557"/>
+            <a:ext cx="14197077" cy="4097066"/>
           </a:xfrm>
           <a:prstGeom prst="rect">
             <a:avLst/>
@@ -4495,7 +4463,24 @@
                 <a:latin typeface="Times New Roman" panose="02020603050405020304" pitchFamily="18" charset="0"/>
                 <a:cs typeface="Times New Roman" panose="02020603050405020304" pitchFamily="18" charset="0"/>
               </a:rPr>
-              <a:t>, 2023. [5] H. Jiao et al., "</a:t>
+              <a:t>, 2023. </a:t>
+            </a:r>
+          </a:p>
+          <a:p>
+            <a:pPr algn="just">
+              <a:spcAft>
+                <a:spcPts val="400"/>
+              </a:spcAft>
+            </a:pPr>
+            <a:r>
+              <a:rPr lang="en-US" sz="2600" dirty="0">
+                <a:solidFill>
+                  <a:schemeClr val="tx1"/>
+                </a:solidFill>
+                <a:latin typeface="Times New Roman" panose="02020603050405020304" pitchFamily="18" charset="0"/>
+                <a:cs typeface="Times New Roman" panose="02020603050405020304" pitchFamily="18" charset="0"/>
+              </a:rPr>
+              <a:t>[5] H. Jiao et al., "</a:t>
             </a:r>
             <a:r>
               <a:rPr lang="en-US" sz="2600" dirty="0" err="1">
@@ -4581,8 +4566,8 @@
         </p:nvSpPr>
         <p:spPr>
           <a:xfrm>
-            <a:off x="15547524" y="2839855"/>
-            <a:ext cx="14197054" cy="640080"/>
+            <a:off x="15547512" y="2839855"/>
+            <a:ext cx="14197066" cy="640080"/>
           </a:xfrm>
           <a:prstGeom prst="rect">
             <a:avLst/>
@@ -4694,34 +4679,34 @@
               </a:spcAft>
             </a:pPr>
             <a:r>
-              <a:rPr sz="2600" b="0" dirty="0">
+              <a:rPr lang="en-IN" sz="2600" b="1" dirty="0">
                 <a:solidFill>
                   <a:srgbClr val="007030"/>
                 </a:solidFill>
                 <a:latin typeface="Times New Roman"/>
               </a:rPr>
-              <a:t>•Qwen2.5-Coder (Winner): </a:t>
-            </a:r>
-            <a:r>
-              <a:rPr lang="en-US" sz="2600" b="0" dirty="0">
+              <a:t>•  </a:t>
+            </a:r>
+            <a:r>
+              <a:rPr sz="2600" b="1" dirty="0">
                 <a:solidFill>
                   <a:srgbClr val="007030"/>
                 </a:solidFill>
                 <a:latin typeface="Times New Roman"/>
               </a:rPr>
-              <a:t>Exc</a:t>
-            </a:r>
-            <a:r>
-              <a:rPr lang="en-US" sz="2600" dirty="0">
+              <a:t>Qwen2.5-Coder (Winner): </a:t>
+            </a:r>
+            <a:r>
+              <a:rPr lang="en-US" sz="2600" b="1" dirty="0">
                 <a:solidFill>
                   <a:srgbClr val="007030"/>
                 </a:solidFill>
                 <a:latin typeface="Times New Roman"/>
               </a:rPr>
-              <a:t>elled at native POSTGIS spatial logic without custom finetuning</a:t>
-            </a:r>
-            <a:r>
-              <a:rPr sz="2600" b="0" dirty="0">
+              <a:t>Excelled at native POSTGIS spatial logic without custom finetuning</a:t>
+            </a:r>
+            <a:r>
+              <a:rPr sz="2600" b="1" dirty="0">
                 <a:solidFill>
                   <a:srgbClr val="007030"/>
                 </a:solidFill>
@@ -4729,7 +4714,7 @@
               </a:rPr>
               <a:t>.</a:t>
             </a:r>
-            <a:endParaRPr lang="en-US" sz="2600" b="0" dirty="0">
+            <a:endParaRPr lang="en-US" sz="2600" b="1" dirty="0">
               <a:solidFill>
                 <a:srgbClr val="007030"/>
               </a:solidFill>
@@ -4743,6 +4728,16 @@
               </a:spcAft>
             </a:pPr>
             <a:r>
+              <a:rPr lang="en-IN" sz="2600" dirty="0">
+                <a:solidFill>
+                  <a:schemeClr val="tx1"/>
+                </a:solidFill>
+                <a:latin typeface="Times New Roman" panose="02020603050405020304" pitchFamily="18" charset="0"/>
+                <a:cs typeface="Times New Roman" panose="02020603050405020304" pitchFamily="18" charset="0"/>
+              </a:rPr>
+              <a:t>• </a:t>
+            </a:r>
+            <a:r>
               <a:rPr sz="2600" dirty="0">
                 <a:solidFill>
                   <a:schemeClr val="tx1"/>
@@ -4750,7 +4745,7 @@
                 <a:latin typeface="Times New Roman" panose="02020603050405020304" pitchFamily="18" charset="0"/>
                 <a:cs typeface="Times New Roman" panose="02020603050405020304" pitchFamily="18" charset="0"/>
               </a:rPr>
-              <a:t>•SQLCoder-8B (Failed): </a:t>
+              <a:t>SQLCoder-8B (Failed): </a:t>
             </a:r>
             <a:r>
               <a:rPr lang="en-US" sz="2600" dirty="0">
@@ -4770,6 +4765,16 @@
               </a:spcAft>
             </a:pPr>
             <a:r>
+              <a:rPr lang="en-IN" sz="2600" dirty="0">
+                <a:solidFill>
+                  <a:schemeClr val="tx1"/>
+                </a:solidFill>
+                <a:latin typeface="Times New Roman" panose="02020603050405020304" pitchFamily="18" charset="0"/>
+                <a:cs typeface="Times New Roman" panose="02020603050405020304" pitchFamily="18" charset="0"/>
+              </a:rPr>
+              <a:t>• </a:t>
+            </a:r>
+            <a:r>
               <a:rPr sz="2600" dirty="0">
                 <a:solidFill>
                   <a:schemeClr val="tx1"/>
@@ -4777,7 +4782,7 @@
                 <a:latin typeface="Times New Roman" panose="02020603050405020304" pitchFamily="18" charset="0"/>
                 <a:cs typeface="Times New Roman" panose="02020603050405020304" pitchFamily="18" charset="0"/>
               </a:rPr>
-              <a:t>•CodeS-7B (Failed): </a:t>
+              <a:t>CodeS-7B (Failed): </a:t>
             </a:r>
             <a:r>
               <a:rPr lang="en-US" sz="2600" dirty="0">
@@ -4804,7 +4809,7 @@
                 <a:latin typeface="Times New Roman" panose="02020603050405020304" pitchFamily="18" charset="0"/>
                 <a:cs typeface="Times New Roman" panose="02020603050405020304" pitchFamily="18" charset="0"/>
               </a:rPr>
-              <a:t>•DeepSeek-Coder-7B (Failed): Struggled with </a:t>
+              <a:t>• DeepSeek-Coder-7B (Failed): Struggled with </a:t>
             </a:r>
             <a:r>
               <a:rPr lang="en-US" sz="2600" dirty="0" err="1">
@@ -4844,14 +4849,14 @@
           <p:nvPr>
             <p:extLst>
               <p:ext uri="{D42A27DB-BD31-4B8C-83A1-F6EECF244321}">
-                <p14:modId xmlns:p14="http://schemas.microsoft.com/office/powerpoint/2010/main" val="2419928385"/>
+                <p14:modId xmlns:p14="http://schemas.microsoft.com/office/powerpoint/2010/main" val="1545341103"/>
               </p:ext>
             </p:extLst>
           </p:nvPr>
         </p:nvGraphicFramePr>
         <p:xfrm>
-          <a:off x="15547517" y="6992903"/>
-          <a:ext cx="14197053" cy="2256540"/>
+          <a:off x="15547505" y="6992903"/>
+          <a:ext cx="14197066" cy="2256540"/>
         </p:xfrm>
         <a:graphic>
           <a:graphicData uri="http://schemas.openxmlformats.org/drawingml/2006/table">
@@ -4860,28 +4865,28 @@
                 <a:tableStyleId>{5C22544A-7EE6-4342-B048-85BDC9FD1C3A}</a:tableStyleId>
               </a:tblPr>
               <a:tblGrid>
-                <a:gridCol w="4764111">
+                <a:gridCol w="4764115">
                   <a:extLst>
                     <a:ext uri="{9D8B030D-6E8A-4147-A177-3AD203B41FA5}">
                       <a16:colId xmlns:a16="http://schemas.microsoft.com/office/drawing/2014/main" val="20000"/>
                     </a:ext>
                   </a:extLst>
                 </a:gridCol>
-                <a:gridCol w="3144314">
+                <a:gridCol w="3144317">
                   <a:extLst>
                     <a:ext uri="{9D8B030D-6E8A-4147-A177-3AD203B41FA5}">
                       <a16:colId xmlns:a16="http://schemas.microsoft.com/office/drawing/2014/main" val="20001"/>
                     </a:ext>
                   </a:extLst>
                 </a:gridCol>
-                <a:gridCol w="3144314">
+                <a:gridCol w="3144317">
                   <a:extLst>
                     <a:ext uri="{9D8B030D-6E8A-4147-A177-3AD203B41FA5}">
                       <a16:colId xmlns:a16="http://schemas.microsoft.com/office/drawing/2014/main" val="20002"/>
                     </a:ext>
                   </a:extLst>
                 </a:gridCol>
-                <a:gridCol w="3144314">
+                <a:gridCol w="3144317">
                   <a:extLst>
                     <a:ext uri="{9D8B030D-6E8A-4147-A177-3AD203B41FA5}">
                       <a16:colId xmlns:a16="http://schemas.microsoft.com/office/drawing/2014/main" val="20003"/>
@@ -5095,7 +5100,7 @@
                     <a:p>
                       <a:pPr algn="l"/>
                       <a:r>
-                        <a:rPr sz="1800" b="0">
+                        <a:rPr sz="1800" b="0" dirty="0">
                           <a:solidFill>
                             <a:srgbClr val="333333"/>
                           </a:solidFill>
@@ -5402,8 +5407,8 @@
         </p:nvSpPr>
         <p:spPr>
           <a:xfrm>
-            <a:off x="15547520" y="9345726"/>
-            <a:ext cx="14197050" cy="640080"/>
+            <a:off x="15547504" y="9345726"/>
+            <a:ext cx="14197066" cy="640080"/>
           </a:xfrm>
           <a:prstGeom prst="rect">
             <a:avLst/>
@@ -5460,8 +5465,8 @@
         </p:nvSpPr>
         <p:spPr>
           <a:xfrm>
-            <a:off x="15547517" y="10168013"/>
-            <a:ext cx="14197054" cy="2653597"/>
+            <a:off x="15547504" y="10168013"/>
+            <a:ext cx="14197067" cy="2776036"/>
           </a:xfrm>
           <a:prstGeom prst="rect">
             <a:avLst/>
@@ -5510,48 +5515,51 @@
             </a:r>
           </a:p>
           <a:p>
+            <a:pPr algn="just"/>
+            <a:r>
+              <a:rPr lang="en-US" sz="2600" b="1" dirty="0">
+                <a:solidFill>
+                  <a:srgbClr val="00702F"/>
+                </a:solidFill>
+                <a:latin typeface="Times New Roman"/>
+              </a:rPr>
+              <a:t>• </a:t>
+            </a:r>
+            <a:r>
+              <a:rPr lang="en-US" sz="2600" b="1" dirty="0">
+                <a:solidFill>
+                  <a:srgbClr val="00702F"/>
+                </a:solidFill>
+                <a:latin typeface="Times New Roman" panose="02020603050405020304" pitchFamily="18" charset="0"/>
+                <a:cs typeface="Times New Roman" panose="02020603050405020304" pitchFamily="18" charset="0"/>
+              </a:rPr>
+              <a:t>Sarvam-Translate (Winner): Successfully normalized complex Hinglish internet slang into formal English suitable for SQL parsing.</a:t>
+            </a:r>
+          </a:p>
+          <a:p>
+            <a:pPr algn="just"/>
             <a:r>
               <a:rPr lang="en-US" sz="2600" dirty="0">
                 <a:solidFill>
-                  <a:srgbClr val="00702F"/>
-                </a:solidFill>
-                <a:latin typeface="Times New Roman"/>
-              </a:rPr>
-              <a:t>• </a:t>
-            </a:r>
+                  <a:schemeClr val="tx1"/>
+                </a:solidFill>
+                <a:latin typeface="Times New Roman" panose="02020603050405020304" pitchFamily="18" charset="0"/>
+                <a:cs typeface="Times New Roman" panose="02020603050405020304" pitchFamily="18" charset="0"/>
+              </a:rPr>
+              <a:t>•  NLLB &amp; Seamless (Failed): Spelled out Hindi slang in English letters instead of translating it, which crashed the SQL engine.</a:t>
+            </a:r>
+          </a:p>
+          <a:p>
+            <a:pPr algn="just"/>
             <a:r>
               <a:rPr lang="en-US" sz="2600" dirty="0">
                 <a:solidFill>
-                  <a:srgbClr val="00702F"/>
-                </a:solidFill>
-                <a:latin typeface="Times New Roman" panose="02020603050405020304" pitchFamily="18" charset="0"/>
-                <a:cs typeface="Times New Roman" panose="02020603050405020304" pitchFamily="18" charset="0"/>
-              </a:rPr>
-              <a:t>Sarvam-Translate (Winner): Successfully normalized complex Hinglish internet slang into formal English suitable for SQL parsing.</a:t>
-            </a:r>
-          </a:p>
-          <a:p>
-            <a:r>
-              <a:rPr lang="en-US" sz="2600" dirty="0">
-                <a:solidFill>
                   <a:schemeClr val="tx1"/>
                 </a:solidFill>
                 <a:latin typeface="Times New Roman" panose="02020603050405020304" pitchFamily="18" charset="0"/>
                 <a:cs typeface="Times New Roman" panose="02020603050405020304" pitchFamily="18" charset="0"/>
               </a:rPr>
-              <a:t>• NLLB &amp; Seamless (Failed): Spelled out Hindi slang in English letters instead of translating it, which crashed the SQL engine.</a:t>
-            </a:r>
-          </a:p>
-          <a:p>
-            <a:r>
-              <a:rPr lang="en-US" sz="2600" dirty="0">
-                <a:solidFill>
-                  <a:schemeClr val="tx1"/>
-                </a:solidFill>
-                <a:latin typeface="Times New Roman" panose="02020603050405020304" pitchFamily="18" charset="0"/>
-                <a:cs typeface="Times New Roman" panose="02020603050405020304" pitchFamily="18" charset="0"/>
-              </a:rPr>
-              <a:t>• Google Translate: Provided a strong accuracy baseline but violated the strict 100% offline requirement.</a:t>
+              <a:t>•  Google Translate: Provided a strong accuracy baseline, but was unable to achieve the strict 100% offline requirement.</a:t>
             </a:r>
           </a:p>
         </p:txBody>
@@ -5571,14 +5579,14 @@
           <p:nvPr>
             <p:extLst>
               <p:ext uri="{D42A27DB-BD31-4B8C-83A1-F6EECF244321}">
-                <p14:modId xmlns:p14="http://schemas.microsoft.com/office/powerpoint/2010/main" val="747104080"/>
+                <p14:modId xmlns:p14="http://schemas.microsoft.com/office/powerpoint/2010/main" val="117287402"/>
               </p:ext>
             </p:extLst>
           </p:nvPr>
         </p:nvGraphicFramePr>
         <p:xfrm>
-          <a:off x="15547520" y="13052073"/>
-          <a:ext cx="14197050" cy="2478515"/>
+          <a:off x="15547503" y="13052073"/>
+          <a:ext cx="14197068" cy="2478515"/>
         </p:xfrm>
         <a:graphic>
           <a:graphicData uri="http://schemas.openxmlformats.org/drawingml/2006/table">
@@ -5587,28 +5595,28 @@
                 <a:tableStyleId>{5C22544A-7EE6-4342-B048-85BDC9FD1C3A}</a:tableStyleId>
               </a:tblPr>
               <a:tblGrid>
-                <a:gridCol w="5070375">
+                <a:gridCol w="5070381">
                   <a:extLst>
                     <a:ext uri="{9D8B030D-6E8A-4147-A177-3AD203B41FA5}">
                       <a16:colId xmlns:a16="http://schemas.microsoft.com/office/drawing/2014/main" val="20000"/>
                     </a:ext>
                   </a:extLst>
                 </a:gridCol>
-                <a:gridCol w="3042225">
+                <a:gridCol w="3042229">
                   <a:extLst>
                     <a:ext uri="{9D8B030D-6E8A-4147-A177-3AD203B41FA5}">
                       <a16:colId xmlns:a16="http://schemas.microsoft.com/office/drawing/2014/main" val="20001"/>
                     </a:ext>
                   </a:extLst>
                 </a:gridCol>
-                <a:gridCol w="3042225">
+                <a:gridCol w="3042229">
                   <a:extLst>
                     <a:ext uri="{9D8B030D-6E8A-4147-A177-3AD203B41FA5}">
                       <a16:colId xmlns:a16="http://schemas.microsoft.com/office/drawing/2014/main" val="20002"/>
                     </a:ext>
                   </a:extLst>
                 </a:gridCol>
-                <a:gridCol w="3042225">
+                <a:gridCol w="3042229">
                   <a:extLst>
                     <a:ext uri="{9D8B030D-6E8A-4147-A177-3AD203B41FA5}">
                       <a16:colId xmlns:a16="http://schemas.microsoft.com/office/drawing/2014/main" val="20003"/>
@@ -5624,7 +5632,7 @@
                     <a:p>
                       <a:pPr algn="ctr"/>
                       <a:r>
-                        <a:rPr sz="2000" b="1">
+                        <a:rPr sz="2000" b="1" dirty="0">
                           <a:solidFill>
                             <a:srgbClr val="FFFFFF"/>
                           </a:solidFill>
@@ -6129,8 +6137,8 @@
         </p:nvSpPr>
         <p:spPr>
           <a:xfrm>
-            <a:off x="15547524" y="15761051"/>
-            <a:ext cx="14197046" cy="640080"/>
+            <a:off x="15547502" y="15761051"/>
+            <a:ext cx="14197068" cy="640080"/>
           </a:xfrm>
           <a:prstGeom prst="rect">
             <a:avLst/>
@@ -6187,8 +6195,8 @@
         </p:nvSpPr>
         <p:spPr>
           <a:xfrm>
-            <a:off x="15547524" y="16611769"/>
-            <a:ext cx="14197046" cy="3138903"/>
+            <a:off x="15547502" y="16611769"/>
+            <a:ext cx="14197068" cy="3138903"/>
           </a:xfrm>
           <a:prstGeom prst="rect">
             <a:avLst/>
@@ -6237,8 +6245,9 @@
             </a:r>
           </a:p>
           <a:p>
-            <a:r>
-              <a:rPr sz="2600" dirty="0">
+            <a:pPr algn="just"/>
+            <a:r>
+              <a:rPr sz="2600" b="1" dirty="0">
                 <a:solidFill>
                   <a:srgbClr val="00702F"/>
                 </a:solidFill>
@@ -6248,7 +6257,7 @@
               <a:t>• </a:t>
             </a:r>
             <a:r>
-              <a:rPr lang="en-US" sz="2600" dirty="0">
+              <a:rPr lang="en-US" sz="2600" b="1" dirty="0">
                 <a:solidFill>
                   <a:srgbClr val="00702F"/>
                 </a:solidFill>
@@ -6272,7 +6281,7 @@
                 <a:latin typeface="Times New Roman" panose="02020603050405020304" pitchFamily="18" charset="0"/>
                 <a:cs typeface="Times New Roman" panose="02020603050405020304" pitchFamily="18" charset="0"/>
               </a:rPr>
-              <a:t>• Sarvam API (Runner-up): </a:t>
+              <a:t>• </a:t>
             </a:r>
             <a:r>
               <a:rPr lang="en-US" sz="2600" dirty="0">
@@ -6282,7 +6291,7 @@
                 <a:latin typeface="Times New Roman" panose="02020603050405020304" pitchFamily="18" charset="0"/>
                 <a:cs typeface="Times New Roman" panose="02020603050405020304" pitchFamily="18" charset="0"/>
               </a:rPr>
-              <a:t>Achieved the highest overall accuracy  </a:t>
+              <a:t>  </a:t>
             </a:r>
             <a:r>
               <a:rPr sz="2600" dirty="0">
@@ -6292,10 +6301,31 @@
                 <a:latin typeface="Times New Roman" panose="02020603050405020304" pitchFamily="18" charset="0"/>
                 <a:cs typeface="Times New Roman" panose="02020603050405020304" pitchFamily="18" charset="0"/>
               </a:rPr>
+              <a:t>Sarvam API (Runner-up): </a:t>
+            </a:r>
+            <a:r>
+              <a:rPr lang="en-US" sz="2600" dirty="0">
+                <a:solidFill>
+                  <a:schemeClr val="tx1"/>
+                </a:solidFill>
+                <a:latin typeface="Times New Roman" panose="02020603050405020304" pitchFamily="18" charset="0"/>
+                <a:cs typeface="Times New Roman" panose="02020603050405020304" pitchFamily="18" charset="0"/>
+              </a:rPr>
+              <a:t>Achieved the highest overall accuracy </a:t>
+            </a:r>
+            <a:r>
+              <a:rPr sz="2600" dirty="0">
+                <a:solidFill>
+                  <a:schemeClr val="tx1"/>
+                </a:solidFill>
+                <a:latin typeface="Times New Roman" panose="02020603050405020304" pitchFamily="18" charset="0"/>
+                <a:cs typeface="Times New Roman" panose="02020603050405020304" pitchFamily="18" charset="0"/>
+              </a:rPr>
               <a:t>but requires internet (API).</a:t>
             </a:r>
           </a:p>
           <a:p>
+            <a:pPr algn="just"/>
             <a:r>
               <a:rPr lang="en-US" sz="2600" dirty="0">
                 <a:solidFill>
@@ -6304,10 +6334,11 @@
                 <a:latin typeface="Times New Roman" panose="02020603050405020304" pitchFamily="18" charset="0"/>
                 <a:cs typeface="Times New Roman" panose="02020603050405020304" pitchFamily="18" charset="0"/>
               </a:rPr>
-              <a:t>• OpenAI Whisper (Failed): Struggled with low-resource Indian languages, failing heavily on Telugu and Marathi audio inputs.</a:t>
-            </a:r>
-          </a:p>
-          <a:p>
+              <a:t>•  OpenAI Whisper (Failed): Struggled with low-resource Indian languages, failing heavily on Telugu and Marathi audio inputs.</a:t>
+            </a:r>
+          </a:p>
+          <a:p>
+            <a:pPr algn="just"/>
             <a:r>
               <a:rPr lang="en-US" sz="2600" dirty="0">
                 <a:solidFill>
@@ -6316,7 +6347,7 @@
                 <a:latin typeface="Times New Roman" panose="02020603050405020304" pitchFamily="18" charset="0"/>
                 <a:cs typeface="Times New Roman" panose="02020603050405020304" pitchFamily="18" charset="0"/>
               </a:rPr>
-              <a:t>• Google Speech (Failed): Provided moderate accuracy but requires internet (API).</a:t>
+              <a:t>•   Google Speech (Failed): Provided moderate accuracy but requires internet (API).</a:t>
             </a:r>
           </a:p>
         </p:txBody>
@@ -6336,14 +6367,14 @@
           <p:nvPr>
             <p:extLst>
               <p:ext uri="{D42A27DB-BD31-4B8C-83A1-F6EECF244321}">
-                <p14:modId xmlns:p14="http://schemas.microsoft.com/office/powerpoint/2010/main" val="99052211"/>
+                <p14:modId xmlns:p14="http://schemas.microsoft.com/office/powerpoint/2010/main" val="3962545494"/>
               </p:ext>
             </p:extLst>
           </p:nvPr>
         </p:nvGraphicFramePr>
         <p:xfrm>
-          <a:off x="15547517" y="19924272"/>
-          <a:ext cx="14197054" cy="2382015"/>
+          <a:off x="15547502" y="19924272"/>
+          <a:ext cx="14197068" cy="2382015"/>
         </p:xfrm>
         <a:graphic>
           <a:graphicData uri="http://schemas.openxmlformats.org/drawingml/2006/table">
@@ -6352,28 +6383,28 @@
                 <a:tableStyleId>{5C22544A-7EE6-4342-B048-85BDC9FD1C3A}</a:tableStyleId>
               </a:tblPr>
               <a:tblGrid>
-                <a:gridCol w="5070376">
+                <a:gridCol w="5070381">
                   <a:extLst>
                     <a:ext uri="{9D8B030D-6E8A-4147-A177-3AD203B41FA5}">
                       <a16:colId xmlns:a16="http://schemas.microsoft.com/office/drawing/2014/main" val="20000"/>
                     </a:ext>
                   </a:extLst>
                 </a:gridCol>
-                <a:gridCol w="3042226">
+                <a:gridCol w="3042229">
                   <a:extLst>
                     <a:ext uri="{9D8B030D-6E8A-4147-A177-3AD203B41FA5}">
                       <a16:colId xmlns:a16="http://schemas.microsoft.com/office/drawing/2014/main" val="20001"/>
                     </a:ext>
                   </a:extLst>
                 </a:gridCol>
-                <a:gridCol w="3042226">
+                <a:gridCol w="3042229">
                   <a:extLst>
                     <a:ext uri="{9D8B030D-6E8A-4147-A177-3AD203B41FA5}">
                       <a16:colId xmlns:a16="http://schemas.microsoft.com/office/drawing/2014/main" val="20002"/>
                     </a:ext>
                   </a:extLst>
                 </a:gridCol>
-                <a:gridCol w="3042226">
+                <a:gridCol w="3042229">
                   <a:extLst>
                     <a:ext uri="{9D8B030D-6E8A-4147-A177-3AD203B41FA5}">
                       <a16:colId xmlns:a16="http://schemas.microsoft.com/office/drawing/2014/main" val="20003"/>
@@ -6894,8 +6925,8 @@
         </p:nvSpPr>
         <p:spPr>
           <a:xfrm>
-            <a:off x="899544" y="28240186"/>
-            <a:ext cx="14356080" cy="640080"/>
+            <a:off x="899544" y="27465220"/>
+            <a:ext cx="14356078" cy="640080"/>
           </a:xfrm>
           <a:prstGeom prst="rect">
             <a:avLst/>
@@ -6952,8 +6983,8 @@
         </p:nvSpPr>
         <p:spPr>
           <a:xfrm>
-            <a:off x="899544" y="28971706"/>
-            <a:ext cx="14356080" cy="5341914"/>
+            <a:off x="899544" y="28196740"/>
+            <a:ext cx="14356078" cy="5341914"/>
           </a:xfrm>
           <a:prstGeom prst="rect">
             <a:avLst/>
@@ -7002,6 +7033,7 @@
             </a:r>
           </a:p>
           <a:p>
+            <a:pPr algn="just"/>
             <a:r>
               <a:rPr sz="2600" dirty="0">
                 <a:solidFill>
@@ -7142,6 +7174,7 @@
             </a:r>
           </a:p>
           <a:p>
+            <a:pPr algn="just"/>
             <a:r>
               <a:rPr sz="2600" dirty="0">
                 <a:solidFill>
@@ -7206,8 +7239,8 @@
         </p:nvSpPr>
         <p:spPr>
           <a:xfrm>
-            <a:off x="15547520" y="32336690"/>
-            <a:ext cx="14197058" cy="640080"/>
+            <a:off x="15547501" y="32258652"/>
+            <a:ext cx="14197077" cy="640080"/>
           </a:xfrm>
           <a:prstGeom prst="rect">
             <a:avLst/>
@@ -7264,8 +7297,8 @@
         </p:nvSpPr>
         <p:spPr>
           <a:xfrm>
-            <a:off x="15547520" y="33068210"/>
-            <a:ext cx="14197058" cy="2608023"/>
+            <a:off x="15547501" y="32966661"/>
+            <a:ext cx="14197077" cy="2608023"/>
           </a:xfrm>
           <a:prstGeom prst="rect">
             <a:avLst/>
@@ -7297,6 +7330,7 @@
           <a:bodyPr wrap="square" lIns="182880" tIns="137160" rIns="182880" bIns="137160" rtlCol="0" anchor="ctr"/>
           <a:lstStyle/>
           <a:p>
+            <a:pPr algn="just"/>
             <a:r>
               <a:rPr lang="en-US" sz="2600" dirty="0">
                 <a:solidFill>
@@ -7305,44 +7339,11 @@
                 <a:latin typeface="Times New Roman" panose="02020603050405020304" pitchFamily="18" charset="0"/>
                 <a:cs typeface="Times New Roman" panose="02020603050405020304" pitchFamily="18" charset="0"/>
               </a:rPr>
-              <a:t>By combining Qwen2.5-Coder's coding ability with SeamlessM4T's translation skills, we successfully proved that rigid text-search can be abandoned in favor of intelligent, mathematical map routing. Most importantly, by integrating voice recognition and interactive maps, we created an engine that lets humans search the world exactly how they think about it—conversationally and naturally.</a:t>
-            </a:r>
-          </a:p>
-          <a:p>
-            <a:endParaRPr sz="2600" b="0" dirty="0">
-              <a:solidFill>
-                <a:srgbClr val="333333"/>
-              </a:solidFill>
-              <a:latin typeface="Times New Roman" panose="02020603050405020304" pitchFamily="18" charset="0"/>
-              <a:cs typeface="Times New Roman" panose="02020603050405020304" pitchFamily="18" charset="0"/>
-            </a:endParaRPr>
-          </a:p>
-          <a:p>
-            <a:pPr algn="just">
-              <a:spcAft>
-                <a:spcPts val="400"/>
-              </a:spcAft>
-            </a:pPr>
-            <a:r>
-              <a:rPr sz="2600" b="1" dirty="0">
-                <a:solidFill>
-                  <a:srgbClr val="007030"/>
-                </a:solidFill>
-                <a:latin typeface="Times New Roman" panose="02020603050405020304" pitchFamily="18" charset="0"/>
-                <a:cs typeface="Times New Roman" panose="02020603050405020304" pitchFamily="18" charset="0"/>
-              </a:rPr>
-              <a:t>Key Achievement: 78% pass rate on complex queries, outperforming SQL models.</a:t>
-            </a:r>
-            <a:r>
-              <a:rPr sz="2600" b="1" dirty="0">
-                <a:solidFill>
-                  <a:schemeClr val="tx1"/>
-                </a:solidFill>
-                <a:latin typeface="Times New Roman" panose="02020603050405020304" pitchFamily="18" charset="0"/>
-                <a:cs typeface="Times New Roman" panose="02020603050405020304" pitchFamily="18" charset="0"/>
-              </a:rPr>
-              <a:t> </a:t>
-            </a:r>
+              <a:t>Qwen2.5-Coder handles SQL generation while SeamlessM4T provides multilingual translation — together, they replace traditional keyword search with intelligent spatial querying. Voice input and interactive maps allow users to search for places the way they naturally speak, in any language. </a:t>
+            </a:r>
+          </a:p>
+          <a:p>
+            <a:pPr algn="just"/>
             <a:endParaRPr lang="en-US" sz="2600" dirty="0">
               <a:solidFill>
                 <a:schemeClr val="tx1"/>
@@ -7350,6 +7351,19 @@
               <a:latin typeface="Times New Roman" panose="02020603050405020304" pitchFamily="18" charset="0"/>
               <a:cs typeface="Times New Roman" panose="02020603050405020304" pitchFamily="18" charset="0"/>
             </a:endParaRPr>
+          </a:p>
+          <a:p>
+            <a:pPr algn="just"/>
+            <a:r>
+              <a:rPr lang="en-US" sz="2600" b="1" dirty="0">
+                <a:solidFill>
+                  <a:srgbClr val="00702F"/>
+                </a:solidFill>
+                <a:latin typeface="Times New Roman" panose="02020603050405020304" pitchFamily="18" charset="0"/>
+                <a:cs typeface="Times New Roman" panose="02020603050405020304" pitchFamily="18" charset="0"/>
+              </a:rPr>
+              <a:t>Key Achievement: A multilingual spatial search pipeline that converts natural language into precise map results.</a:t>
+            </a:r>
           </a:p>
         </p:txBody>
       </p:sp>
@@ -7367,8 +7381,8 @@
         </p:nvSpPr>
         <p:spPr>
           <a:xfrm>
-            <a:off x="15547517" y="22440530"/>
-            <a:ext cx="14197054" cy="640080"/>
+            <a:off x="15547502" y="22440530"/>
+            <a:ext cx="14197069" cy="640080"/>
           </a:xfrm>
           <a:prstGeom prst="rect">
             <a:avLst/>
@@ -7425,8 +7439,8 @@
         </p:nvSpPr>
         <p:spPr>
           <a:xfrm>
-            <a:off x="15547512" y="23273813"/>
-            <a:ext cx="14197058" cy="8911880"/>
+            <a:off x="15547501" y="23273813"/>
+            <a:ext cx="14197069" cy="8911880"/>
           </a:xfrm>
           <a:prstGeom prst="rect">
             <a:avLst/>
@@ -7507,8 +7521,8 @@
         </p:nvSpPr>
         <p:spPr>
           <a:xfrm>
-            <a:off x="872966" y="12881610"/>
-            <a:ext cx="14356080" cy="640080"/>
+            <a:off x="872965" y="12106644"/>
+            <a:ext cx="14382657" cy="640080"/>
           </a:xfrm>
           <a:prstGeom prst="rect">
             <a:avLst/>
@@ -7565,8 +7579,8 @@
         </p:nvSpPr>
         <p:spPr>
           <a:xfrm>
-            <a:off x="872966" y="13613129"/>
-            <a:ext cx="14356080" cy="3653355"/>
+            <a:off x="872966" y="12838163"/>
+            <a:ext cx="14382656" cy="3653355"/>
           </a:xfrm>
           <a:prstGeom prst="rect">
             <a:avLst/>
@@ -7759,8 +7773,8 @@
         </p:nvSpPr>
         <p:spPr>
           <a:xfrm>
-            <a:off x="899544" y="17573539"/>
-            <a:ext cx="14356080" cy="640080"/>
+            <a:off x="899544" y="16798573"/>
+            <a:ext cx="14356078" cy="640080"/>
           </a:xfrm>
           <a:prstGeom prst="rect">
             <a:avLst/>
@@ -7817,8 +7831,8 @@
         </p:nvSpPr>
         <p:spPr>
           <a:xfrm>
-            <a:off x="899544" y="18305059"/>
-            <a:ext cx="14356080" cy="3931920"/>
+            <a:off x="899544" y="17530093"/>
+            <a:ext cx="14356078" cy="3931920"/>
           </a:xfrm>
           <a:prstGeom prst="rect">
             <a:avLst/>
@@ -7982,8 +7996,8 @@
         </p:nvSpPr>
         <p:spPr>
           <a:xfrm>
-            <a:off x="899544" y="22374139"/>
-            <a:ext cx="14356080" cy="640080"/>
+            <a:off x="899544" y="21599173"/>
+            <a:ext cx="14356078" cy="640080"/>
           </a:xfrm>
           <a:prstGeom prst="rect">
             <a:avLst/>
@@ -8040,8 +8054,8 @@
         </p:nvSpPr>
         <p:spPr>
           <a:xfrm>
-            <a:off x="899544" y="23130521"/>
-            <a:ext cx="14356080" cy="4904653"/>
+            <a:off x="899544" y="22355555"/>
+            <a:ext cx="14356078" cy="4904653"/>
           </a:xfrm>
           <a:prstGeom prst="rect">
             <a:avLst/>
@@ -8247,8 +8261,8 @@
         </p:nvSpPr>
         <p:spPr>
           <a:xfrm>
-            <a:off x="872966" y="34498272"/>
-            <a:ext cx="14356080" cy="640080"/>
+            <a:off x="872966" y="33723306"/>
+            <a:ext cx="14382656" cy="640080"/>
           </a:xfrm>
           <a:prstGeom prst="rect">
             <a:avLst/>
@@ -8305,8 +8319,8 @@
         </p:nvSpPr>
         <p:spPr>
           <a:xfrm>
-            <a:off x="872966" y="35323004"/>
-            <a:ext cx="14356080" cy="5086824"/>
+            <a:off x="872966" y="34459014"/>
+            <a:ext cx="14356080" cy="5950814"/>
           </a:xfrm>
           <a:prstGeom prst="rect">
             <a:avLst/>
@@ -8343,36 +8357,6 @@
           </a:p>
         </p:txBody>
       </p:sp>
-      <p:pic>
-        <p:nvPicPr>
-          <p:cNvPr id="30" name="Picture 29">
-            <a:extLst>
-              <a:ext uri="{FF2B5EF4-FFF2-40B4-BE49-F238E27FC236}">
-                <a16:creationId xmlns:a16="http://schemas.microsoft.com/office/drawing/2014/main" id="{1E706B35-6584-6339-CD65-532066F8B86F}"/>
-              </a:ext>
-            </a:extLst>
-          </p:cNvPr>
-          <p:cNvPicPr>
-            <a:picLocks noChangeAspect="1"/>
-          </p:cNvPicPr>
-          <p:nvPr/>
-        </p:nvPicPr>
-        <p:blipFill>
-          <a:blip r:embed="rId4"/>
-          <a:stretch>
-            <a:fillRect/>
-          </a:stretch>
-        </p:blipFill>
-        <p:spPr>
-          <a:xfrm>
-            <a:off x="945264" y="35356082"/>
-            <a:ext cx="14238062" cy="5008237"/>
-          </a:xfrm>
-          <a:prstGeom prst="rect">
-            <a:avLst/>
-          </a:prstGeom>
-        </p:spPr>
-      </p:pic>
       <p:sp>
         <p:nvSpPr>
           <p:cNvPr id="26" name="TextBox 25">
@@ -8387,8 +8371,8 @@
         </p:nvSpPr>
         <p:spPr>
           <a:xfrm>
-            <a:off x="8964270" y="139218"/>
-            <a:ext cx="13327419" cy="861774"/>
+            <a:off x="8075595" y="139218"/>
+            <a:ext cx="15961047" cy="861774"/>
           </a:xfrm>
           <a:prstGeom prst="rect">
             <a:avLst/>
@@ -8401,28 +8385,29 @@
           </a:bodyPr>
           <a:lstStyle/>
           <a:p>
-            <a:r>
-              <a:rPr lang="en-IN" sz="5000" dirty="0">
+            <a:pPr algn="ctr"/>
+            <a:r>
+              <a:rPr lang="en-IN" sz="4800" dirty="0">
                 <a:latin typeface="Times New Roman" panose="02020603050405020304" pitchFamily="18" charset="0"/>
                 <a:cs typeface="Times New Roman" panose="02020603050405020304" pitchFamily="18" charset="0"/>
               </a:rPr>
               <a:t>Visiting Summer Research Internship (</a:t>
             </a:r>
             <a:r>
-              <a:rPr lang="en-IN" sz="5000" dirty="0" err="1">
+              <a:rPr lang="en-IN" sz="4800" dirty="0" err="1">
                 <a:latin typeface="Times New Roman" panose="02020603050405020304" pitchFamily="18" charset="0"/>
                 <a:cs typeface="Times New Roman" panose="02020603050405020304" pitchFamily="18" charset="0"/>
               </a:rPr>
               <a:t>ViSRI</a:t>
             </a:r>
             <a:r>
-              <a:rPr lang="en-IN" sz="5000" dirty="0">
+              <a:rPr lang="en-IN" sz="4800" dirty="0">
                 <a:latin typeface="Times New Roman" panose="02020603050405020304" pitchFamily="18" charset="0"/>
                 <a:cs typeface="Times New Roman" panose="02020603050405020304" pitchFamily="18" charset="0"/>
               </a:rPr>
               <a:t>) 2026</a:t>
             </a:r>
-            <a:endParaRPr lang="en-US" sz="5000" b="1" i="1" dirty="0">
+            <a:endParaRPr lang="en-US" sz="4800" b="1" i="1" dirty="0">
               <a:solidFill>
                 <a:srgbClr val="002060"/>
               </a:solidFill>
@@ -8447,7 +8432,7 @@
           <p:nvPr/>
         </p:nvPicPr>
         <p:blipFill>
-          <a:blip r:embed="rId5">
+          <a:blip r:embed="rId4">
             <a:extLst>
               <a:ext uri="{28A0092B-C50C-407E-A947-70E740481C1C}">
                 <a14:useLocalDpi xmlns:a14="http://schemas.microsoft.com/office/drawing/2010/main" val="0"/>
@@ -8460,8 +8445,8 @@
         </p:blipFill>
         <p:spPr>
           <a:xfrm>
-            <a:off x="0" y="-140859"/>
-            <a:ext cx="7983525" cy="2661176"/>
+            <a:off x="96521" y="53129"/>
+            <a:ext cx="7401560" cy="2467188"/>
           </a:xfrm>
           <a:prstGeom prst="rect">
             <a:avLst/>
@@ -8483,7 +8468,7 @@
           <p:nvPr/>
         </p:nvPicPr>
         <p:blipFill>
-          <a:blip r:embed="rId6">
+          <a:blip r:embed="rId5">
             <a:extLst>
               <a:ext uri="{28A0092B-C50C-407E-A947-70E740481C1C}">
                 <a14:useLocalDpi xmlns:a14="http://schemas.microsoft.com/office/drawing/2010/main" val="0"/>
@@ -8497,7 +8482,7 @@
         </p:blipFill>
         <p:spPr bwMode="auto">
           <a:xfrm>
-            <a:off x="24036643" y="55745"/>
+            <a:off x="24036643" y="137025"/>
             <a:ext cx="5943600" cy="1984491"/>
           </a:xfrm>
           <a:prstGeom prst="rect">
@@ -8589,7 +8574,7 @@
                 <a:latin typeface="Times New Roman" panose="02020603050405020304" pitchFamily="18" charset="0"/>
                 <a:cs typeface="Times New Roman" panose="02020603050405020304" pitchFamily="18" charset="0"/>
               </a:rPr>
-              <a:t>Candidate name: Mayank Pillai                                                        Supervisor(s): Prof. Yashvardhan Sharma</a:t>
+              <a:t>Candidate Name: Mayank Pillai                                            Supervisor: Prof. Yashvardhan Sharma</a:t>
             </a:r>
           </a:p>
           <a:p>
@@ -8598,7 +8583,7 @@
                 <a:latin typeface="Times New Roman" panose="02020603050405020304" pitchFamily="18" charset="0"/>
                 <a:cs typeface="Times New Roman" panose="02020603050405020304" pitchFamily="18" charset="0"/>
               </a:rPr>
-              <a:t>Institute Name: Newton School of Technology		              				  Department: CSIS</a:t>
+              <a:t>Institute Name: Newton School of Technology		              	Department: Computer Science &amp; Information Systems</a:t>
             </a:r>
             <a:endParaRPr lang="en-US" sz="4500" b="1" i="1" baseline="30000" dirty="0">
               <a:latin typeface="Times New Roman" panose="02020603050405020304" pitchFamily="18" charset="0"/>
@@ -8608,6 +8593,36 @@
           </a:p>
         </p:txBody>
       </p:sp>
+      <p:pic>
+        <p:nvPicPr>
+          <p:cNvPr id="10" name="Picture 9">
+            <a:extLst>
+              <a:ext uri="{FF2B5EF4-FFF2-40B4-BE49-F238E27FC236}">
+                <a16:creationId xmlns:a16="http://schemas.microsoft.com/office/drawing/2014/main" id="{75286E8D-A30B-ACA4-C750-BCCE0CB9DCEE}"/>
+              </a:ext>
+            </a:extLst>
+          </p:cNvPr>
+          <p:cNvPicPr>
+            <a:picLocks noChangeAspect="1"/>
+          </p:cNvPicPr>
+          <p:nvPr/>
+        </p:nvPicPr>
+        <p:blipFill>
+          <a:blip r:embed="rId6"/>
+          <a:stretch>
+            <a:fillRect/>
+          </a:stretch>
+        </p:blipFill>
+        <p:spPr>
+          <a:xfrm>
+            <a:off x="899544" y="34459014"/>
+            <a:ext cx="14329502" cy="5950814"/>
+          </a:xfrm>
+          <a:prstGeom prst="rect">
+            <a:avLst/>
+          </a:prstGeom>
+        </p:spPr>
+      </p:pic>
     </p:spTree>
     <p:extLst>
       <p:ext uri="{BB962C8B-B14F-4D97-AF65-F5344CB8AC3E}">

</xml_diff>